<commit_message>
Name the hackathon as Kai Sandai in the pitch deck
Co-Authored-By: Claude Opus 5.5 <noreply@anthropic.com>
Claude-Session: https://claude.ai/code/session_01BW3kYPWSDDkCpLrbd7zPGL
</commit_message>
<xml_diff>
--- a/presentation/KrishiMitra_AI_Hackathon.pptx
+++ b/presentation/KrishiMitra_AI_Hackathon.pptx
@@ -121,20 +121,20 @@
   <p:extLst>
     <p:ext uri="{521415D9-36F7-43E2-AB2F-B90AF26B5E84}">
       <p14:sectionLst xmlns:p14="http://schemas.microsoft.com/office/powerpoint/2010/main">
-        <p14:section name="Introduction" id="{9052519f-ac27-92df-6da9-2c9bb2210f21}">
+        <p14:section name="Introduction" id="{91fd7206-6c41-54b7-53c5-f70375020146}">
           <p14:sldIdLst>
             <p14:sldId id="256"/>
             <p14:sldId id="257"/>
           </p14:sldIdLst>
         </p14:section>
-        <p14:section name="The Problem" id="{e4a542a0-c1f2-79f3-a5a4-0f2cafd4c6e2}">
+        <p14:section name="The Problem" id="{12423129-a8f1-4204-f43b-710d4bd964cf}">
           <p14:sldIdLst>
             <p14:sldId id="258"/>
             <p14:sldId id="259"/>
             <p14:sldId id="260"/>
           </p14:sldIdLst>
         </p14:section>
-        <p14:section name="The Solution" id="{f6e94ab9-f28f-6748-9596-463ccd327566}">
+        <p14:section name="The Solution" id="{11811f70-9194-d1df-ec6b-95e7f6bd075d}">
           <p14:sldIdLst>
             <p14:sldId id="261"/>
             <p14:sldId id="262"/>
@@ -143,7 +143,7 @@
             <p14:sldId id="265"/>
           </p14:sldIdLst>
         </p14:section>
-        <p14:section name="The Harvest" id="{8d1924ba-e8e5-e90c-5ca9-52557b12edd4}">
+        <p14:section name="The Harvest" id="{b22d801f-4c41-256c-e54c-19ea727f6290}">
           <p14:sldIdLst>
             <p14:sldId id="266"/>
             <p14:sldId id="267"/>
@@ -151,7 +151,7 @@
             <p14:sldId id="269"/>
           </p14:sldIdLst>
         </p14:section>
-        <p14:section name="Close" id="{6295efa7-5bb1-11dc-e3ef-15eede441a01}">
+        <p14:section name="Close" id="{2694fc18-7436-6666-5b56-1fd33a7f0786}">
           <p14:sldIdLst>
             <p14:sldId id="270"/>
           </p14:sldIdLst>
@@ -836,7 +836,7 @@
           <a:p>
             <a:r>
               <a:rPr lang="en-US" dirty="0"/>
-              <a:t>Good morning, judges. We are [team name]. Our project is KrishiMitra AI: Krishi means farming and Mitra means friend. It's an AI friend in every farmer's pocket that helps them diagnose crop disease, beat the weather and get a fair price, all in their own language.</a:t>
+              <a:t>Good morning, judges, and thank you to the Kai Sandai Hackathon. We are [team name]. Our project is KrishiMitra AI: Krishi means farming and Mitra means friend. It's an AI friend in every farmer's pocket that helps them diagnose crop disease, beat the weather and get a fair price, all in their own language.</a:t>
             </a:r>
             <a:endParaRPr lang="en-US" dirty="0"/>
           </a:p>
@@ -2396,7 +2396,7 @@
                   <a:schemeClr val="bg2"/>
                 </a:solidFill>
               </a:rPr>
-              <a:t>KrishiMitra AI  ·  Hackathon 2026</a:t>
+              <a:t>KrishiMitra AI  ·  Kai Sandai Hackathon</a:t>
             </a:r>
             <a:endParaRPr lang="en-US" sz="1000" dirty="0"/>
           </a:p>
@@ -2884,7 +2884,7 @@
         <p:spPr>
           <a:xfrm>
             <a:off x="731520" y="1417320"/>
-            <a:ext cx="6400800" cy="320040"/>
+            <a:ext cx="7498080" cy="320040"/>
           </a:xfrm>
           <a:prstGeom prst="rect">
             <a:avLst/>
@@ -2905,7 +2905,7 @@
                   <a:schemeClr val="accent1"/>
                 </a:solidFill>
               </a:rPr>
-              <a:t>HACKATHON 2026  ·  AGRITECH TRACK</a:t>
+              <a:t>KAI SANDAI HACKATHON  ·  AGRITECH TRACK</a:t>
             </a:r>
             <a:endParaRPr lang="en-US" sz="1400" dirty="0"/>
           </a:p>
@@ -10257,7 +10257,7 @@
                   <a:schemeClr val="bg2"/>
                 </a:solidFill>
               </a:rPr>
-              <a:t>[Your Team Name]  ·  KrishiMitra AI  ·  Hackathon 2026</a:t>
+              <a:t>[Your Team Name]  ·  KrishiMitra AI  ·  Kai Sandai Hackathon</a:t>
             </a:r>
             <a:endParaRPr lang="en-US" sz="1300" dirty="0"/>
           </a:p>

</xml_diff>